<commit_message>
Use each map panel own southern crop in geographic inset
</commit_message>
<xml_diff>
--- a/final_results/figures/Map_figures_editable.pptx
+++ b/final_results/figures/Map_figures_editable.pptx
@@ -505,7 +505,7 @@
           <a:lstStyle/>
           <a:p>
             <a:r>
-              <a:t>Fig2. The grayscale South China Sea inset is geographical reference artwork extracted from the supplied PowerPoint. It is not a quantitative result layer. Move or resize the inset independently of the map background.</a:t>
+              <a:t>Fig2. Each inset combines the southern crop from its own map panel with reference island outlines from the supplied PowerPoint. Move or resize the inset independently of the background.</a:t>
             </a:r>
           </a:p>
         </p:txBody>
@@ -575,7 +575,7 @@
           <a:lstStyle/>
           <a:p>
             <a:r>
-              <a:t>Fig3. The grayscale South China Sea inset is geographical reference artwork extracted from the supplied PowerPoint. It is not a quantitative result layer. Move or resize the inset independently of the map background.</a:t>
+              <a:t>Fig3. Each inset combines the southern crop from its own map panel with reference island outlines from the supplied PowerPoint. Move or resize the inset independently of the background.</a:t>
             </a:r>
           </a:p>
         </p:txBody>
@@ -645,7 +645,7 @@
           <a:lstStyle/>
           <a:p>
             <a:r>
-              <a:t>Fig4. The grayscale South China Sea inset is geographical reference artwork extracted from the supplied PowerPoint. It is not a quantitative result layer. Move or resize the inset independently of the map background.</a:t>
+              <a:t>Fig4. Each inset combines the southern crop from its own map panel with reference island outlines from the supplied PowerPoint. Move or resize the inset independently of the background.</a:t>
             </a:r>
           </a:p>
         </p:txBody>
@@ -715,7 +715,7 @@
           <a:lstStyle/>
           <a:p>
             <a:r>
-              <a:t>Fig_S1. The grayscale South China Sea inset is geographical reference artwork extracted from the supplied PowerPoint. It is not a quantitative result layer. Move or resize the inset independently of the map background.</a:t>
+              <a:t>Fig_S1. Each inset combines the southern crop from its own map panel with reference island outlines from the supplied PowerPoint. Move or resize the inset independently of the background.</a:t>
             </a:r>
           </a:p>
         </p:txBody>
@@ -3747,7 +3747,7 @@
       </p:pic>
       <p:pic>
         <p:nvPicPr>
-          <p:cNvPr id="3" name="Fig2 geographic inset 1" descr="south_china_sea_reference.png"/>
+          <p:cNvPr id="3" name="Fig2 geographic inset 1" descr="Fig2_panel_1_inset.png"/>
           <p:cNvPicPr>
             <a:picLocks noChangeAspect="1"/>
           </p:cNvPicPr>
@@ -3761,8 +3761,8 @@
         </p:blipFill>
         <p:spPr>
           <a:xfrm>
-            <a:off x="2810223" y="3474722"/>
-            <a:ext cx="519560" cy="692529"/>
+            <a:off x="2803696" y="3473909"/>
+            <a:ext cx="519935" cy="692787"/>
           </a:xfrm>
           <a:prstGeom prst="rect">
             <a:avLst/>
@@ -3771,22 +3771,22 @@
       </p:pic>
       <p:pic>
         <p:nvPicPr>
-          <p:cNvPr id="4" name="Fig2 geographic inset 2" descr="south_china_sea_reference.png"/>
+          <p:cNvPr id="4" name="Fig2 geographic inset 2" descr="Fig2_panel_2_inset.png"/>
           <p:cNvPicPr>
             <a:picLocks noChangeAspect="1"/>
           </p:cNvPicPr>
           <p:nvPr/>
         </p:nvPicPr>
         <p:blipFill>
-          <a:blip r:embed="rId3"/>
+          <a:blip r:embed="rId4"/>
           <a:stretch>
             <a:fillRect/>
           </a:stretch>
         </p:blipFill>
         <p:spPr>
           <a:xfrm>
-            <a:off x="6674959" y="3474722"/>
-            <a:ext cx="519560" cy="692529"/>
+            <a:off x="6671221" y="3473909"/>
+            <a:ext cx="519935" cy="692787"/>
           </a:xfrm>
           <a:prstGeom prst="rect">
             <a:avLst/>
@@ -3795,22 +3795,22 @@
       </p:pic>
       <p:pic>
         <p:nvPicPr>
-          <p:cNvPr id="5" name="Fig2 geographic inset 3" descr="south_china_sea_reference.png"/>
+          <p:cNvPr id="5" name="Fig2 geographic inset 3" descr="Fig2_panel_3_inset.png"/>
           <p:cNvPicPr>
             <a:picLocks noChangeAspect="1"/>
           </p:cNvPicPr>
           <p:nvPr/>
         </p:nvPicPr>
         <p:blipFill>
-          <a:blip r:embed="rId3"/>
+          <a:blip r:embed="rId5"/>
           <a:stretch>
             <a:fillRect/>
           </a:stretch>
         </p:blipFill>
         <p:spPr>
           <a:xfrm>
-            <a:off x="11043020" y="3301590"/>
-            <a:ext cx="649450" cy="865661"/>
+            <a:off x="11042433" y="3300712"/>
+            <a:ext cx="649919" cy="865984"/>
           </a:xfrm>
           <a:prstGeom prst="rect">
             <a:avLst/>
@@ -3861,7 +3861,7 @@
       </p:pic>
       <p:pic>
         <p:nvPicPr>
-          <p:cNvPr id="3" name="Fig3 geographic inset 1" descr="south_china_sea_reference.png"/>
+          <p:cNvPr id="3" name="Fig3 geographic inset 1" descr="Fig3_panel_1_inset.png"/>
           <p:cNvPicPr>
             <a:picLocks noChangeAspect="1"/>
           </p:cNvPicPr>
@@ -3875,8 +3875,8 @@
         </p:blipFill>
         <p:spPr>
           <a:xfrm>
-            <a:off x="4871418" y="4002785"/>
-            <a:ext cx="1016881" cy="1356742"/>
+            <a:off x="4869135" y="4003257"/>
+            <a:ext cx="1018777" cy="1357857"/>
           </a:xfrm>
           <a:prstGeom prst="rect">
             <a:avLst/>
@@ -3885,22 +3885,22 @@
       </p:pic>
       <p:pic>
         <p:nvPicPr>
-          <p:cNvPr id="4" name="Fig3 geographic inset 2" descr="south_china_sea_reference.png"/>
+          <p:cNvPr id="4" name="Fig3 geographic inset 2" descr="Fig3_panel_2_inset.png"/>
           <p:cNvPicPr>
             <a:picLocks noChangeAspect="1"/>
           </p:cNvPicPr>
           <p:nvPr/>
         </p:nvPicPr>
         <p:blipFill>
-          <a:blip r:embed="rId3"/>
+          <a:blip r:embed="rId4"/>
           <a:stretch>
             <a:fillRect/>
           </a:stretch>
         </p:blipFill>
         <p:spPr>
           <a:xfrm>
-            <a:off x="9833141" y="4274134"/>
-            <a:ext cx="813505" cy="1085393"/>
+            <a:off x="9840108" y="4274828"/>
+            <a:ext cx="815021" cy="1086285"/>
           </a:xfrm>
           <a:prstGeom prst="rect">
             <a:avLst/>
@@ -3951,7 +3951,7 @@
       </p:pic>
       <p:pic>
         <p:nvPicPr>
-          <p:cNvPr id="3" name="Fig4 geographic inset 1" descr="south_china_sea_reference.png"/>
+          <p:cNvPr id="3" name="Fig4 geographic inset 1" descr="Fig4_panel_1_inset.png"/>
           <p:cNvPicPr>
             <a:picLocks noChangeAspect="1"/>
           </p:cNvPicPr>
@@ -3965,8 +3965,8 @@
         </p:blipFill>
         <p:spPr>
           <a:xfrm>
-            <a:off x="4593019" y="2147664"/>
-            <a:ext cx="565443" cy="754336"/>
+            <a:off x="4584543" y="2146918"/>
+            <a:ext cx="566246" cy="754775"/>
           </a:xfrm>
           <a:prstGeom prst="rect">
             <a:avLst/>
@@ -4017,7 +4017,7 @@
       </p:pic>
       <p:pic>
         <p:nvPicPr>
-          <p:cNvPr id="3" name="Fig_S1 geographic inset 1" descr="south_china_sea_reference.png"/>
+          <p:cNvPr id="3" name="Fig_S1 geographic inset 1" descr="Fig_S1_panel_1_inset.png"/>
           <p:cNvPicPr>
             <a:picLocks noChangeAspect="1"/>
           </p:cNvPicPr>
@@ -4031,8 +4031,8 @@
         </p:blipFill>
         <p:spPr>
           <a:xfrm>
-            <a:off x="4514768" y="3576788"/>
-            <a:ext cx="601216" cy="801561"/>
+            <a:off x="4542612" y="3580610"/>
+            <a:ext cx="608377" cy="811109"/>
           </a:xfrm>
           <a:prstGeom prst="rect">
             <a:avLst/>

</xml_diff>